<commit_message>
Update content of C stage file slide
</commit_message>
<xml_diff>
--- a/Slide/C/4.C_stage_File.pptx
+++ b/Slide/C/4.C_stage_File.pptx
@@ -267,7 +267,7 @@
           <a:p>
             <a:fld id="{ECA3AE87-C17F-4F2C-92FF-7FE21F8A66BE}" type="datetimeFigureOut">
               <a:rPr lang="en-US" smtClean="0"/>
-              <a:t>4/24/2025</a:t>
+              <a:t>1/12/2026</a:t>
             </a:fld>
             <a:endParaRPr lang="en-US"/>
           </a:p>
@@ -435,7 +435,7 @@
           <a:p>
             <a:fld id="{ECA3AE87-C17F-4F2C-92FF-7FE21F8A66BE}" type="datetimeFigureOut">
               <a:rPr lang="en-US" smtClean="0"/>
-              <a:t>4/24/2025</a:t>
+              <a:t>1/12/2026</a:t>
             </a:fld>
             <a:endParaRPr lang="en-US"/>
           </a:p>
@@ -613,7 +613,7 @@
           <a:p>
             <a:fld id="{ECA3AE87-C17F-4F2C-92FF-7FE21F8A66BE}" type="datetimeFigureOut">
               <a:rPr lang="en-US" smtClean="0"/>
-              <a:t>4/24/2025</a:t>
+              <a:t>1/12/2026</a:t>
             </a:fld>
             <a:endParaRPr lang="en-US"/>
           </a:p>
@@ -781,7 +781,7 @@
           <a:p>
             <a:fld id="{ECA3AE87-C17F-4F2C-92FF-7FE21F8A66BE}" type="datetimeFigureOut">
               <a:rPr lang="en-US" smtClean="0"/>
-              <a:t>4/24/2025</a:t>
+              <a:t>1/12/2026</a:t>
             </a:fld>
             <a:endParaRPr lang="en-US"/>
           </a:p>
@@ -1026,7 +1026,7 @@
           <a:p>
             <a:fld id="{ECA3AE87-C17F-4F2C-92FF-7FE21F8A66BE}" type="datetimeFigureOut">
               <a:rPr lang="en-US" smtClean="0"/>
-              <a:t>4/24/2025</a:t>
+              <a:t>1/12/2026</a:t>
             </a:fld>
             <a:endParaRPr lang="en-US"/>
           </a:p>
@@ -1255,7 +1255,7 @@
           <a:p>
             <a:fld id="{ECA3AE87-C17F-4F2C-92FF-7FE21F8A66BE}" type="datetimeFigureOut">
               <a:rPr lang="en-US" smtClean="0"/>
-              <a:t>4/24/2025</a:t>
+              <a:t>1/12/2026</a:t>
             </a:fld>
             <a:endParaRPr lang="en-US"/>
           </a:p>
@@ -1619,7 +1619,7 @@
           <a:p>
             <a:fld id="{ECA3AE87-C17F-4F2C-92FF-7FE21F8A66BE}" type="datetimeFigureOut">
               <a:rPr lang="en-US" smtClean="0"/>
-              <a:t>4/24/2025</a:t>
+              <a:t>1/12/2026</a:t>
             </a:fld>
             <a:endParaRPr lang="en-US"/>
           </a:p>
@@ -1736,7 +1736,7 @@
           <a:p>
             <a:fld id="{ECA3AE87-C17F-4F2C-92FF-7FE21F8A66BE}" type="datetimeFigureOut">
               <a:rPr lang="en-US" smtClean="0"/>
-              <a:t>4/24/2025</a:t>
+              <a:t>1/12/2026</a:t>
             </a:fld>
             <a:endParaRPr lang="en-US"/>
           </a:p>
@@ -1831,7 +1831,7 @@
           <a:p>
             <a:fld id="{ECA3AE87-C17F-4F2C-92FF-7FE21F8A66BE}" type="datetimeFigureOut">
               <a:rPr lang="en-US" smtClean="0"/>
-              <a:t>4/24/2025</a:t>
+              <a:t>1/12/2026</a:t>
             </a:fld>
             <a:endParaRPr lang="en-US"/>
           </a:p>
@@ -2106,7 +2106,7 @@
           <a:p>
             <a:fld id="{ECA3AE87-C17F-4F2C-92FF-7FE21F8A66BE}" type="datetimeFigureOut">
               <a:rPr lang="en-US" smtClean="0"/>
-              <a:t>4/24/2025</a:t>
+              <a:t>1/12/2026</a:t>
             </a:fld>
             <a:endParaRPr lang="en-US"/>
           </a:p>
@@ -2358,7 +2358,7 @@
           <a:p>
             <a:fld id="{ECA3AE87-C17F-4F2C-92FF-7FE21F8A66BE}" type="datetimeFigureOut">
               <a:rPr lang="en-US" smtClean="0"/>
-              <a:t>4/24/2025</a:t>
+              <a:t>1/12/2026</a:t>
             </a:fld>
             <a:endParaRPr lang="en-US"/>
           </a:p>
@@ -2569,7 +2569,7 @@
           <a:p>
             <a:fld id="{ECA3AE87-C17F-4F2C-92FF-7FE21F8A66BE}" type="datetimeFigureOut">
               <a:rPr lang="en-US" smtClean="0"/>
-              <a:t>4/24/2025</a:t>
+              <a:t>1/12/2026</a:t>
             </a:fld>
             <a:endParaRPr lang="en-US"/>
           </a:p>
@@ -6518,7 +6518,7 @@
           <a:p>
             <a:r>
               <a:rPr lang="en-US" dirty="0"/>
-              <a:t>assembler</a:t>
+              <a:t>compiler</a:t>
             </a:r>
           </a:p>
         </p:txBody>
@@ -6626,7 +6626,7 @@
         </p:nvSpPr>
         <p:spPr>
           <a:xfrm>
-            <a:off x="9779267" y="4926697"/>
+            <a:off x="9779267" y="5792971"/>
             <a:ext cx="1070008" cy="866274"/>
           </a:xfrm>
           <a:prstGeom prst="rect">
@@ -6677,7 +6677,7 @@
         <p:spPr>
           <a:xfrm>
             <a:off x="10314271" y="4591251"/>
-            <a:ext cx="0" cy="335446"/>
+            <a:ext cx="0" cy="1201720"/>
           </a:xfrm>
           <a:prstGeom prst="straightConnector1">
             <a:avLst/>
@@ -6701,6 +6701,76 @@
           </a:fontRef>
         </p:style>
       </p:cxnSp>
+      <p:sp>
+        <p:nvSpPr>
+          <p:cNvPr id="5" name="TextBox 4">
+            <a:extLst>
+              <a:ext uri="{FF2B5EF4-FFF2-40B4-BE49-F238E27FC236}">
+                <a16:creationId xmlns:a16="http://schemas.microsoft.com/office/drawing/2014/main" id="{74804E7F-FE26-C7DE-DC72-093B847CCE81}"/>
+              </a:ext>
+            </a:extLst>
+          </p:cNvPr>
+          <p:cNvSpPr txBox="1"/>
+          <p:nvPr/>
+        </p:nvSpPr>
+        <p:spPr>
+          <a:xfrm>
+            <a:off x="9779267" y="2917893"/>
+            <a:ext cx="1212783" cy="369332"/>
+          </a:xfrm>
+          <a:prstGeom prst="rect">
+            <a:avLst/>
+          </a:prstGeom>
+          <a:noFill/>
+        </p:spPr>
+        <p:txBody>
+          <a:bodyPr wrap="square" rtlCol="0">
+            <a:spAutoFit/>
+          </a:bodyPr>
+          <a:lstStyle/>
+          <a:p>
+            <a:r>
+              <a:rPr lang="en-US" dirty="0"/>
+              <a:t>assembler</a:t>
+            </a:r>
+          </a:p>
+        </p:txBody>
+      </p:sp>
+      <p:sp>
+        <p:nvSpPr>
+          <p:cNvPr id="8" name="TextBox 7">
+            <a:extLst>
+              <a:ext uri="{FF2B5EF4-FFF2-40B4-BE49-F238E27FC236}">
+                <a16:creationId xmlns:a16="http://schemas.microsoft.com/office/drawing/2014/main" id="{41F4272F-47E9-9489-0DAF-59F497AAD253}"/>
+              </a:ext>
+            </a:extLst>
+          </p:cNvPr>
+          <p:cNvSpPr txBox="1"/>
+          <p:nvPr/>
+        </p:nvSpPr>
+        <p:spPr>
+          <a:xfrm>
+            <a:off x="10674417" y="4950764"/>
+            <a:ext cx="962526" cy="369332"/>
+          </a:xfrm>
+          <a:prstGeom prst="rect">
+            <a:avLst/>
+          </a:prstGeom>
+          <a:noFill/>
+        </p:spPr>
+        <p:txBody>
+          <a:bodyPr wrap="square" rtlCol="0">
+            <a:spAutoFit/>
+          </a:bodyPr>
+          <a:lstStyle/>
+          <a:p>
+            <a:r>
+              <a:rPr lang="en-US" dirty="0"/>
+              <a:t>linking</a:t>
+            </a:r>
+          </a:p>
+        </p:txBody>
+      </p:sp>
     </p:spTree>
     <p:extLst>
       <p:ext uri="{BB962C8B-B14F-4D97-AF65-F5344CB8AC3E}">

</xml_diff>